<commit_message>
made changes after EOS26
</commit_message>
<xml_diff>
--- a/gratings/grating_simulations_reininger.pptx
+++ b/gratings/grating_simulations_reininger.pptx
@@ -354,7 +354,7 @@
           <a:p>
             <a:fld id="{1D8BD707-D9CF-40AE-B4C6-C98DA3205C09}" type="datetimeFigureOut">
               <a:rPr lang="en-US"/>
-              <a:t>20/04/2026</a:t>
+              <a:t>19/05/2026</a:t>
             </a:fld>
             <a:endParaRPr lang="en-US"/>
           </a:p>
@@ -615,7 +615,7 @@
           <a:p>
             <a:fld id="{1D8BD707-D9CF-40AE-B4C6-C98DA3205C09}" type="datetimeFigureOut">
               <a:rPr lang="en-US"/>
-              <a:t>20/04/2026</a:t>
+              <a:t>19/05/2026</a:t>
             </a:fld>
             <a:endParaRPr lang="en-US"/>
           </a:p>
@@ -913,7 +913,7 @@
           <a:p>
             <a:fld id="{1D8BD707-D9CF-40AE-B4C6-C98DA3205C09}" type="datetimeFigureOut">
               <a:rPr lang="en-US"/>
-              <a:t>20/04/2026</a:t>
+              <a:t>19/05/2026</a:t>
             </a:fld>
             <a:endParaRPr lang="en-US"/>
           </a:p>
@@ -1153,7 +1153,7 @@
           <a:p>
             <a:fld id="{1D8BD707-D9CF-40AE-B4C6-C98DA3205C09}" type="datetimeFigureOut">
               <a:rPr lang="en-US"/>
-              <a:t>20/04/2026</a:t>
+              <a:t>19/05/2026</a:t>
             </a:fld>
             <a:endParaRPr lang="en-US"/>
           </a:p>
@@ -1356,7 +1356,7 @@
           <a:p>
             <a:fld id="{1D8BD707-D9CF-40AE-B4C6-C98DA3205C09}" type="datetimeFigureOut">
               <a:rPr lang="en-US"/>
-              <a:t>20/04/2026</a:t>
+              <a:t>19/05/2026</a:t>
             </a:fld>
             <a:endParaRPr lang="en-US"/>
           </a:p>
@@ -1687,7 +1687,7 @@
           <a:p>
             <a:fld id="{1D8BD707-D9CF-40AE-B4C6-C98DA3205C09}" type="datetimeFigureOut">
               <a:rPr lang="en-US"/>
-              <a:t>20/04/2026</a:t>
+              <a:t>19/05/2026</a:t>
             </a:fld>
             <a:endParaRPr lang="en-US"/>
           </a:p>
@@ -31926,220 +31926,6 @@
       </p:sp>
       <p:sp>
         <p:nvSpPr>
-          <p:cNvPr id="9" name="object 9"/>
-          <p:cNvSpPr txBox="1"/>
-          <p:nvPr/>
-        </p:nvSpPr>
-        <p:spPr>
-          <a:xfrm>
-            <a:off x="11412958" y="6419047"/>
-            <a:ext cx="1550035" cy="3244477"/>
-          </a:xfrm>
-          <a:prstGeom prst="rect">
-            <a:avLst/>
-          </a:prstGeom>
-        </p:spPr>
-        <p:txBody>
-          <a:bodyPr vert="horz" wrap="square" lIns="0" tIns="33019" rIns="0" bIns="0" rtlCol="0">
-            <a:spAutoFit/>
-          </a:bodyPr>
-          <a:lstStyle/>
-          <a:p>
-            <a:pPr marL="12700" marR="280670">
-              <a:lnSpc>
-                <a:spcPts val="2800"/>
-              </a:lnSpc>
-              <a:spcBef>
-                <a:spcPts val="259"/>
-              </a:spcBef>
-            </a:pPr>
-            <a:r>
-              <a:rPr sz="1600" dirty="0">
-                <a:latin typeface="Arial MT"/>
-                <a:cs typeface="Arial MT"/>
-              </a:rPr>
-              <a:t>With</a:t>
-            </a:r>
-            <a:r>
-              <a:rPr sz="1600" spc="-30" dirty="0">
-                <a:latin typeface="Arial MT"/>
-                <a:cs typeface="Arial MT"/>
-              </a:rPr>
-              <a:t> </a:t>
-            </a:r>
-            <a:endParaRPr lang="en-US" sz="1600" spc="-30" dirty="0">
-              <a:latin typeface="Arial MT"/>
-              <a:cs typeface="Arial MT"/>
-            </a:endParaRPr>
-          </a:p>
-          <a:p>
-            <a:pPr marL="12700" marR="280670">
-              <a:lnSpc>
-                <a:spcPts val="2800"/>
-              </a:lnSpc>
-              <a:spcBef>
-                <a:spcPts val="259"/>
-              </a:spcBef>
-            </a:pPr>
-            <a:r>
-              <a:rPr sz="1600" spc="-25" dirty="0">
-                <a:latin typeface="Arial MT"/>
-                <a:cs typeface="Arial MT"/>
-              </a:rPr>
-              <a:t>S</a:t>
-            </a:r>
-            <a:r>
-              <a:rPr lang="en-US" sz="1600" spc="-25" dirty="0">
-                <a:latin typeface="Arial MT"/>
-                <a:cs typeface="Arial MT"/>
-              </a:rPr>
-              <a:t>lope </a:t>
-            </a:r>
-            <a:r>
-              <a:rPr sz="1600" spc="-25" dirty="0">
-                <a:latin typeface="Arial MT"/>
-                <a:cs typeface="Arial MT"/>
-              </a:rPr>
-              <a:t>E</a:t>
-            </a:r>
-            <a:r>
-              <a:rPr lang="en-US" sz="1600" spc="-25" dirty="0">
-                <a:latin typeface="Arial MT"/>
-                <a:cs typeface="Arial MT"/>
-              </a:rPr>
-              <a:t>rrors</a:t>
-            </a:r>
-            <a:r>
-              <a:rPr sz="1600" spc="-25" dirty="0">
-                <a:latin typeface="Arial MT"/>
-                <a:cs typeface="Arial MT"/>
-              </a:rPr>
-              <a:t> </a:t>
-            </a:r>
-            <a:r>
-              <a:rPr sz="1600" dirty="0">
-                <a:latin typeface="Arial MT"/>
-                <a:cs typeface="Arial MT"/>
-              </a:rPr>
-              <a:t>on</a:t>
-            </a:r>
-            <a:r>
-              <a:rPr sz="1600" spc="-75" dirty="0">
-                <a:latin typeface="Arial MT"/>
-                <a:cs typeface="Arial MT"/>
-              </a:rPr>
-              <a:t> </a:t>
-            </a:r>
-            <a:r>
-              <a:rPr sz="1600" spc="-55" dirty="0">
-                <a:latin typeface="Arial MT"/>
-                <a:cs typeface="Arial MT"/>
-              </a:rPr>
-              <a:t>Toroid</a:t>
-            </a:r>
-            <a:endParaRPr lang="en-US" sz="1600" spc="-55" dirty="0">
-              <a:latin typeface="Arial MT"/>
-              <a:cs typeface="Arial MT"/>
-            </a:endParaRPr>
-          </a:p>
-          <a:p>
-            <a:pPr marL="12700" marR="280670">
-              <a:lnSpc>
-                <a:spcPts val="2800"/>
-              </a:lnSpc>
-              <a:spcBef>
-                <a:spcPts val="259"/>
-              </a:spcBef>
-            </a:pPr>
-            <a:endParaRPr lang="en-US" sz="1600" spc="-55" dirty="0">
-              <a:latin typeface="Arial MT"/>
-              <a:cs typeface="Arial MT"/>
-            </a:endParaRPr>
-          </a:p>
-          <a:p>
-            <a:pPr marL="12700" marR="280670">
-              <a:lnSpc>
-                <a:spcPts val="2800"/>
-              </a:lnSpc>
-              <a:spcBef>
-                <a:spcPts val="259"/>
-              </a:spcBef>
-            </a:pPr>
-            <a:r>
-              <a:rPr lang="en-US" sz="1600" spc="-55" dirty="0">
-                <a:latin typeface="Arial MT"/>
-                <a:cs typeface="Arial MT"/>
-              </a:rPr>
-              <a:t>Without </a:t>
-            </a:r>
-          </a:p>
-          <a:p>
-            <a:pPr marL="12700" marR="280670">
-              <a:lnSpc>
-                <a:spcPts val="2800"/>
-              </a:lnSpc>
-              <a:spcBef>
-                <a:spcPts val="259"/>
-              </a:spcBef>
-            </a:pPr>
-            <a:r>
-              <a:rPr lang="en-US" sz="1600" spc="-55" dirty="0">
-                <a:latin typeface="Arial MT"/>
-                <a:cs typeface="Arial MT"/>
-              </a:rPr>
-              <a:t>Slope Errors </a:t>
-            </a:r>
-          </a:p>
-          <a:p>
-            <a:pPr marL="12700" marR="280670">
-              <a:lnSpc>
-                <a:spcPts val="2800"/>
-              </a:lnSpc>
-              <a:spcBef>
-                <a:spcPts val="259"/>
-              </a:spcBef>
-            </a:pPr>
-            <a:r>
-              <a:rPr lang="en-US" sz="1600" spc="-55" dirty="0">
-                <a:latin typeface="Arial MT"/>
-                <a:cs typeface="Arial MT"/>
-              </a:rPr>
-              <a:t>On Toroid</a:t>
-            </a:r>
-            <a:endParaRPr sz="1600" dirty="0">
-              <a:latin typeface="Arial MT"/>
-              <a:cs typeface="Arial MT"/>
-            </a:endParaRPr>
-          </a:p>
-          <a:p>
-            <a:pPr>
-              <a:lnSpc>
-                <a:spcPct val="100000"/>
-              </a:lnSpc>
-            </a:pPr>
-            <a:endParaRPr sz="1600" dirty="0">
-              <a:latin typeface="Arial MT"/>
-              <a:cs typeface="Arial MT"/>
-            </a:endParaRPr>
-          </a:p>
-          <a:p>
-            <a:pPr>
-              <a:lnSpc>
-                <a:spcPct val="100000"/>
-              </a:lnSpc>
-              <a:spcBef>
-                <a:spcPts val="80"/>
-              </a:spcBef>
-            </a:pPr>
-            <a:endParaRPr sz="1600" dirty="0">
-              <a:latin typeface="Arial MT"/>
-              <a:cs typeface="Arial MT"/>
-            </a:endParaRPr>
-          </a:p>
-        </p:txBody>
-      </p:sp>
-      <p:sp>
-        <p:nvSpPr>
           <p:cNvPr id="14" name="object 14"/>
           <p:cNvSpPr txBox="1">
             <a:spLocks noGrp="1"/>
@@ -32424,96 +32210,6 @@
           </a:fontRef>
         </p:style>
       </p:cxnSp>
-      <p:pic>
-        <p:nvPicPr>
-          <p:cNvPr id="4" name="Picture 3">
-            <a:extLst>
-              <a:ext uri="{FF2B5EF4-FFF2-40B4-BE49-F238E27FC236}">
-                <a16:creationId xmlns:a16="http://schemas.microsoft.com/office/drawing/2014/main" id="{42E22C17-503E-46B9-BACF-C3841A9B3F88}"/>
-              </a:ext>
-            </a:extLst>
-          </p:cNvPr>
-          <p:cNvPicPr>
-            <a:picLocks noChangeAspect="1"/>
-          </p:cNvPicPr>
-          <p:nvPr/>
-        </p:nvPicPr>
-        <p:blipFill>
-          <a:blip r:embed="rId5"/>
-          <a:stretch>
-            <a:fillRect/>
-          </a:stretch>
-        </p:blipFill>
-        <p:spPr>
-          <a:xfrm>
-            <a:off x="7183519" y="2216810"/>
-            <a:ext cx="4802148" cy="4067005"/>
-          </a:xfrm>
-          <a:prstGeom prst="rect">
-            <a:avLst/>
-          </a:prstGeom>
-        </p:spPr>
-      </p:pic>
-      <p:pic>
-        <p:nvPicPr>
-          <p:cNvPr id="5" name="Picture 4">
-            <a:extLst>
-              <a:ext uri="{FF2B5EF4-FFF2-40B4-BE49-F238E27FC236}">
-                <a16:creationId xmlns:a16="http://schemas.microsoft.com/office/drawing/2014/main" id="{4F798D18-29A6-4FAC-BB94-32BEE1E1DEBC}"/>
-              </a:ext>
-            </a:extLst>
-          </p:cNvPr>
-          <p:cNvPicPr>
-            <a:picLocks noChangeAspect="1"/>
-          </p:cNvPicPr>
-          <p:nvPr/>
-        </p:nvPicPr>
-        <p:blipFill>
-          <a:blip r:embed="rId6"/>
-          <a:stretch>
-            <a:fillRect/>
-          </a:stretch>
-        </p:blipFill>
-        <p:spPr>
-          <a:xfrm>
-            <a:off x="8026400" y="6605644"/>
-            <a:ext cx="3060311" cy="785756"/>
-          </a:xfrm>
-          <a:prstGeom prst="rect">
-            <a:avLst/>
-          </a:prstGeom>
-        </p:spPr>
-      </p:pic>
-      <p:pic>
-        <p:nvPicPr>
-          <p:cNvPr id="6" name="Picture 5">
-            <a:extLst>
-              <a:ext uri="{FF2B5EF4-FFF2-40B4-BE49-F238E27FC236}">
-                <a16:creationId xmlns:a16="http://schemas.microsoft.com/office/drawing/2014/main" id="{BDDF2CA3-2C32-4F4F-9DD1-F743D187BFE8}"/>
-              </a:ext>
-            </a:extLst>
-          </p:cNvPr>
-          <p:cNvPicPr>
-            <a:picLocks noChangeAspect="1"/>
-          </p:cNvPicPr>
-          <p:nvPr/>
-        </p:nvPicPr>
-        <p:blipFill>
-          <a:blip r:embed="rId7"/>
-          <a:stretch>
-            <a:fillRect/>
-          </a:stretch>
-        </p:blipFill>
-        <p:spPr>
-          <a:xfrm>
-            <a:off x="8070434" y="8065954"/>
-            <a:ext cx="3201226" cy="785756"/>
-          </a:xfrm>
-          <a:prstGeom prst="rect">
-            <a:avLst/>
-          </a:prstGeom>
-        </p:spPr>
-      </p:pic>
     </p:spTree>
     <p:extLst>
       <p:ext uri="{BB962C8B-B14F-4D97-AF65-F5344CB8AC3E}">
@@ -34955,6 +34651,217 @@
           </p:spPr>
         </p:pic>
       </p:grpSp>
+      <p:sp>
+        <p:nvSpPr>
+          <p:cNvPr id="43" name="object 13">
+            <a:extLst>
+              <a:ext uri="{FF2B5EF4-FFF2-40B4-BE49-F238E27FC236}">
+                <a16:creationId xmlns:a16="http://schemas.microsoft.com/office/drawing/2014/main" id="{46415788-0915-4648-989C-5558CACB2AFE}"/>
+              </a:ext>
+            </a:extLst>
+          </p:cNvPr>
+          <p:cNvSpPr txBox="1"/>
+          <p:nvPr/>
+        </p:nvSpPr>
+        <p:spPr>
+          <a:xfrm>
+            <a:off x="3318929" y="4959228"/>
+            <a:ext cx="6946899" cy="764312"/>
+          </a:xfrm>
+          <a:prstGeom prst="rect">
+            <a:avLst/>
+          </a:prstGeom>
+        </p:spPr>
+        <p:txBody>
+          <a:bodyPr vert="horz" wrap="square" lIns="0" tIns="12700" rIns="0" bIns="0" rtlCol="0">
+            <a:spAutoFit/>
+          </a:bodyPr>
+          <a:lstStyle/>
+          <a:p>
+            <a:pPr marL="12700">
+              <a:lnSpc>
+                <a:spcPct val="100000"/>
+              </a:lnSpc>
+              <a:spcBef>
+                <a:spcPts val="100"/>
+              </a:spcBef>
+            </a:pPr>
+            <a:r>
+              <a:rPr sz="2400" dirty="0">
+                <a:latin typeface="Arial MT"/>
+                <a:cs typeface="Arial MT"/>
+              </a:rPr>
+              <a:t>R.</a:t>
+            </a:r>
+            <a:r>
+              <a:rPr sz="2400" spc="-55" dirty="0">
+                <a:latin typeface="Arial MT"/>
+                <a:cs typeface="Arial MT"/>
+              </a:rPr>
+              <a:t> </a:t>
+            </a:r>
+            <a:r>
+              <a:rPr sz="2400" dirty="0">
+                <a:latin typeface="Arial MT"/>
+                <a:cs typeface="Arial MT"/>
+              </a:rPr>
+              <a:t>Follath</a:t>
+            </a:r>
+            <a:r>
+              <a:rPr sz="2400" spc="-35" dirty="0">
+                <a:latin typeface="Arial MT"/>
+                <a:cs typeface="Arial MT"/>
+              </a:rPr>
+              <a:t> </a:t>
+            </a:r>
+            <a:r>
+              <a:rPr sz="2400" dirty="0">
+                <a:latin typeface="Arial MT"/>
+                <a:cs typeface="Arial MT"/>
+              </a:rPr>
+              <a:t>and</a:t>
+            </a:r>
+            <a:r>
+              <a:rPr sz="2400" spc="-40" dirty="0">
+                <a:latin typeface="Arial MT"/>
+                <a:cs typeface="Arial MT"/>
+              </a:rPr>
+              <a:t> </a:t>
+            </a:r>
+            <a:r>
+              <a:rPr sz="2400" spc="-110" dirty="0">
+                <a:latin typeface="Arial MT"/>
+                <a:cs typeface="Arial MT"/>
+              </a:rPr>
+              <a:t>F.</a:t>
+            </a:r>
+            <a:r>
+              <a:rPr sz="2400" spc="-40" dirty="0">
+                <a:latin typeface="Arial MT"/>
+                <a:cs typeface="Arial MT"/>
+              </a:rPr>
+              <a:t> </a:t>
+            </a:r>
+            <a:r>
+              <a:rPr sz="2400" dirty="0">
+                <a:latin typeface="Arial MT"/>
+                <a:cs typeface="Arial MT"/>
+              </a:rPr>
+              <a:t>Senf,</a:t>
+            </a:r>
+            <a:r>
+              <a:rPr sz="2400" spc="-40" dirty="0">
+                <a:latin typeface="Arial MT"/>
+                <a:cs typeface="Arial MT"/>
+              </a:rPr>
+              <a:t> </a:t>
+            </a:r>
+            <a:r>
+              <a:rPr sz="2400" spc="-10" dirty="0">
+                <a:latin typeface="Arial MT"/>
+                <a:cs typeface="Arial MT"/>
+              </a:rPr>
+              <a:t>NIM</a:t>
+            </a:r>
+            <a:r>
+              <a:rPr sz="2400" spc="-155" dirty="0">
+                <a:latin typeface="Arial MT"/>
+                <a:cs typeface="Arial MT"/>
+              </a:rPr>
+              <a:t> </a:t>
+            </a:r>
+            <a:r>
+              <a:rPr sz="2400" dirty="0">
+                <a:latin typeface="Arial MT"/>
+                <a:cs typeface="Arial MT"/>
+              </a:rPr>
+              <a:t>A</a:t>
+            </a:r>
+            <a:r>
+              <a:rPr sz="2400" spc="-165" dirty="0">
+                <a:latin typeface="Arial MT"/>
+                <a:cs typeface="Arial MT"/>
+              </a:rPr>
+              <a:t> </a:t>
+            </a:r>
+            <a:r>
+              <a:rPr sz="2400" b="1" dirty="0">
+                <a:latin typeface="Arial"/>
+                <a:cs typeface="Arial"/>
+              </a:rPr>
+              <a:t>390</a:t>
+            </a:r>
+            <a:r>
+              <a:rPr sz="2400" dirty="0">
+                <a:latin typeface="Arial MT"/>
+                <a:cs typeface="Arial MT"/>
+              </a:rPr>
+              <a:t>,</a:t>
+            </a:r>
+            <a:r>
+              <a:rPr sz="2400" spc="-45" dirty="0">
+                <a:latin typeface="Arial MT"/>
+                <a:cs typeface="Arial MT"/>
+              </a:rPr>
+              <a:t> </a:t>
+            </a:r>
+            <a:r>
+              <a:rPr sz="2400" dirty="0">
+                <a:latin typeface="Arial MT"/>
+                <a:cs typeface="Arial MT"/>
+              </a:rPr>
+              <a:t>388</a:t>
+            </a:r>
+            <a:r>
+              <a:rPr sz="2400" spc="-35" dirty="0">
+                <a:latin typeface="Arial MT"/>
+                <a:cs typeface="Arial MT"/>
+              </a:rPr>
+              <a:t> </a:t>
+            </a:r>
+            <a:r>
+              <a:rPr sz="2400" spc="-10" dirty="0">
+                <a:latin typeface="Arial MT"/>
+                <a:cs typeface="Arial MT"/>
+              </a:rPr>
+              <a:t>(1997)</a:t>
+            </a:r>
+            <a:endParaRPr lang="en-US" sz="2400" spc="-10" dirty="0">
+              <a:latin typeface="Arial MT"/>
+              <a:cs typeface="Arial MT"/>
+            </a:endParaRPr>
+          </a:p>
+          <a:p>
+            <a:pPr marL="12700">
+              <a:lnSpc>
+                <a:spcPct val="100000"/>
+              </a:lnSpc>
+              <a:spcBef>
+                <a:spcPts val="100"/>
+              </a:spcBef>
+            </a:pPr>
+            <a:r>
+              <a:rPr lang="en-GB" sz="2400" dirty="0">
+                <a:latin typeface="Arial MT"/>
+                <a:cs typeface="Arial MT"/>
+                <a:hlinkClick r:id="rId4"/>
+              </a:rPr>
+              <a:t>https://doi.org/10.1016/S0168-9002(97)00401-4</a:t>
+            </a:r>
+            <a:r>
+              <a:rPr lang="en-GB" sz="2400" dirty="0">
+                <a:latin typeface="Arial MT"/>
+                <a:cs typeface="Arial MT"/>
+              </a:rPr>
+              <a:t> </a:t>
+            </a:r>
+            <a:endParaRPr sz="2400" dirty="0">
+              <a:latin typeface="Arial MT"/>
+              <a:cs typeface="Arial MT"/>
+            </a:endParaRPr>
+          </a:p>
+        </p:txBody>
+      </p:sp>
     </p:spTree>
   </p:cSld>
   <p:clrMapOvr>
@@ -38719,10 +38626,10 @@
       </p:pic>
       <p:sp>
         <p:nvSpPr>
-          <p:cNvPr id="49" name="object 8">
+          <p:cNvPr id="54" name="object 15">
             <a:extLst>
               <a:ext uri="{FF2B5EF4-FFF2-40B4-BE49-F238E27FC236}">
-                <a16:creationId xmlns:a16="http://schemas.microsoft.com/office/drawing/2014/main" id="{8E948CEE-81B5-4642-B7B1-D6CAFAB66718}"/>
+                <a16:creationId xmlns:a16="http://schemas.microsoft.com/office/drawing/2014/main" id="{8646E698-6D29-406B-82E7-C5C3EFB57F83}"/>
               </a:ext>
             </a:extLst>
           </p:cNvPr>
@@ -38731,8 +38638,8 @@
         </p:nvSpPr>
         <p:spPr>
           <a:xfrm>
-            <a:off x="11061700" y="3835400"/>
-            <a:ext cx="1126490" cy="391160"/>
+            <a:off x="9887164" y="6699964"/>
+            <a:ext cx="2307376" cy="382156"/>
           </a:xfrm>
           <a:prstGeom prst="rect">
             <a:avLst/>
@@ -38757,69 +38664,6 @@
                 <a:latin typeface="Arial MT"/>
                 <a:cs typeface="Arial MT"/>
               </a:rPr>
-              <a:t>With</a:t>
-            </a:r>
-            <a:r>
-              <a:rPr sz="2400" spc="-30" dirty="0">
-                <a:latin typeface="Arial MT"/>
-                <a:cs typeface="Arial MT"/>
-              </a:rPr>
-              <a:t> </a:t>
-            </a:r>
-            <a:r>
-              <a:rPr sz="2400" spc="-25" dirty="0">
-                <a:latin typeface="Arial MT"/>
-                <a:cs typeface="Arial MT"/>
-              </a:rPr>
-              <a:t>SE</a:t>
-            </a:r>
-            <a:endParaRPr sz="2400" dirty="0">
-              <a:latin typeface="Arial MT"/>
-              <a:cs typeface="Arial MT"/>
-            </a:endParaRPr>
-          </a:p>
-        </p:txBody>
-      </p:sp>
-      <p:sp>
-        <p:nvSpPr>
-          <p:cNvPr id="54" name="object 15">
-            <a:extLst>
-              <a:ext uri="{FF2B5EF4-FFF2-40B4-BE49-F238E27FC236}">
-                <a16:creationId xmlns:a16="http://schemas.microsoft.com/office/drawing/2014/main" id="{8646E698-6D29-406B-82E7-C5C3EFB57F83}"/>
-              </a:ext>
-            </a:extLst>
-          </p:cNvPr>
-          <p:cNvSpPr txBox="1"/>
-          <p:nvPr/>
-        </p:nvSpPr>
-        <p:spPr>
-          <a:xfrm>
-            <a:off x="11171555" y="6729150"/>
-            <a:ext cx="906780" cy="391160"/>
-          </a:xfrm>
-          <a:prstGeom prst="rect">
-            <a:avLst/>
-          </a:prstGeom>
-        </p:spPr>
-        <p:txBody>
-          <a:bodyPr vert="horz" wrap="square" lIns="0" tIns="12700" rIns="0" bIns="0" rtlCol="0">
-            <a:spAutoFit/>
-          </a:bodyPr>
-          <a:lstStyle/>
-          <a:p>
-            <a:pPr marL="12700">
-              <a:lnSpc>
-                <a:spcPct val="100000"/>
-              </a:lnSpc>
-              <a:spcBef>
-                <a:spcPts val="100"/>
-              </a:spcBef>
-            </a:pPr>
-            <a:r>
-              <a:rPr sz="2400" dirty="0">
-                <a:latin typeface="Arial MT"/>
-                <a:cs typeface="Arial MT"/>
-              </a:rPr>
               <a:t>No</a:t>
             </a:r>
             <a:r>
@@ -38830,11 +38674,11 @@
               <a:t> </a:t>
             </a:r>
             <a:r>
-              <a:rPr sz="2400" spc="-25" dirty="0">
+              <a:rPr lang="en-US" sz="2400" spc="-25" dirty="0">
                 <a:latin typeface="Arial MT"/>
                 <a:cs typeface="Arial MT"/>
               </a:rPr>
-              <a:t>SE</a:t>
+              <a:t>slope errors</a:t>
             </a:r>
             <a:endParaRPr sz="2400" dirty="0">
               <a:latin typeface="Arial MT"/>
@@ -39004,6 +38848,76 @@
             <a:endParaRPr sz="3600" baseline="3472">
               <a:latin typeface="Arial"/>
               <a:cs typeface="Arial"/>
+            </a:endParaRPr>
+          </a:p>
+        </p:txBody>
+      </p:sp>
+      <p:sp>
+        <p:nvSpPr>
+          <p:cNvPr id="4" name="TextBox 3">
+            <a:extLst>
+              <a:ext uri="{FF2B5EF4-FFF2-40B4-BE49-F238E27FC236}">
+                <a16:creationId xmlns:a16="http://schemas.microsoft.com/office/drawing/2014/main" id="{18A1184A-465C-47A0-B968-A3A4B6B0EFD6}"/>
+              </a:ext>
+            </a:extLst>
+          </p:cNvPr>
+          <p:cNvSpPr txBox="1"/>
+          <p:nvPr/>
+        </p:nvSpPr>
+        <p:spPr>
+          <a:xfrm>
+            <a:off x="9887164" y="3850651"/>
+            <a:ext cx="2492349" cy="461665"/>
+          </a:xfrm>
+          <a:prstGeom prst="rect">
+            <a:avLst/>
+          </a:prstGeom>
+          <a:noFill/>
+        </p:spPr>
+        <p:txBody>
+          <a:bodyPr wrap="none" rtlCol="0">
+            <a:spAutoFit/>
+          </a:bodyPr>
+          <a:lstStyle/>
+          <a:p>
+            <a:r>
+              <a:rPr lang="en-GB" sz="2400" dirty="0">
+                <a:latin typeface="Arial MT"/>
+                <a:cs typeface="Arial MT"/>
+              </a:rPr>
+              <a:t>With</a:t>
+            </a:r>
+            <a:r>
+              <a:rPr lang="en-GB" sz="2400" spc="-50" dirty="0">
+                <a:latin typeface="Arial MT"/>
+                <a:cs typeface="Arial MT"/>
+              </a:rPr>
+              <a:t> </a:t>
+            </a:r>
+            <a:r>
+              <a:rPr lang="en-GB" sz="2400" dirty="0">
+                <a:latin typeface="Arial MT"/>
+                <a:cs typeface="Arial MT"/>
+              </a:rPr>
+              <a:t>slope</a:t>
+            </a:r>
+            <a:r>
+              <a:rPr lang="en-GB" sz="2400" spc="-45" dirty="0">
+                <a:latin typeface="Arial MT"/>
+                <a:cs typeface="Arial MT"/>
+              </a:rPr>
+              <a:t> </a:t>
+            </a:r>
+            <a:r>
+              <a:rPr lang="en-GB" sz="2400" spc="-10" dirty="0">
+                <a:latin typeface="Arial MT"/>
+                <a:cs typeface="Arial MT"/>
+              </a:rPr>
+              <a:t>errors</a:t>
+            </a:r>
+            <a:endParaRPr lang="en-GB" sz="2400" dirty="0">
+              <a:latin typeface="Arial MT"/>
+              <a:cs typeface="Arial MT"/>
             </a:endParaRPr>
           </a:p>
         </p:txBody>
@@ -39443,8 +39357,8 @@
         </p:nvSpPr>
         <p:spPr>
           <a:xfrm>
-            <a:off x="9334500" y="5702300"/>
-            <a:ext cx="2752725" cy="391160"/>
+            <a:off x="9527858" y="5702300"/>
+            <a:ext cx="2512059" cy="391160"/>
           </a:xfrm>
           <a:prstGeom prst="rect">
             <a:avLst/>
@@ -39465,24 +39379,24 @@
               </a:spcBef>
             </a:pPr>
             <a:r>
+              <a:rPr lang="en-US" sz="2400" dirty="0">
+                <a:latin typeface="Arial MT"/>
+                <a:cs typeface="Arial MT"/>
+              </a:rPr>
+              <a:t>No</a:t>
+            </a:r>
+            <a:r>
+              <a:rPr sz="2400" spc="-65" dirty="0">
+                <a:latin typeface="Arial MT"/>
+                <a:cs typeface="Arial MT"/>
+              </a:rPr>
+              <a:t> </a:t>
+            </a:r>
+            <a:r>
               <a:rPr sz="2400" dirty="0">
                 <a:latin typeface="Arial MT"/>
                 <a:cs typeface="Arial MT"/>
               </a:rPr>
-              <a:t>Without</a:t>
-            </a:r>
-            <a:r>
-              <a:rPr sz="2400" spc="-65" dirty="0">
-                <a:latin typeface="Arial MT"/>
-                <a:cs typeface="Arial MT"/>
-              </a:rPr>
-              <a:t> </a:t>
-            </a:r>
-            <a:r>
-              <a:rPr sz="2400" dirty="0">
-                <a:latin typeface="Arial MT"/>
-                <a:cs typeface="Arial MT"/>
-              </a:rPr>
               <a:t>slope</a:t>
             </a:r>
             <a:r>
@@ -39499,7 +39413,7 @@
               </a:rPr>
               <a:t>errors</a:t>
             </a:r>
-            <a:endParaRPr sz="2400">
+            <a:endParaRPr sz="2400" dirty="0">
               <a:latin typeface="Arial MT"/>
               <a:cs typeface="Arial MT"/>
             </a:endParaRPr>
@@ -39844,7 +39758,7 @@
               </a:rPr>
               <a:t>=87.4°</a:t>
             </a:r>
-            <a:endParaRPr sz="2400">
+            <a:endParaRPr sz="2400" dirty="0">
               <a:latin typeface="Arial MT"/>
               <a:cs typeface="Arial MT"/>
             </a:endParaRPr>
@@ -39858,7 +39772,7 @@
                 <a:spcPts val="459"/>
               </a:spcBef>
             </a:pPr>
-            <a:endParaRPr sz="2400">
+            <a:endParaRPr sz="2400" dirty="0">
               <a:latin typeface="Arial MT"/>
               <a:cs typeface="Arial MT"/>
             </a:endParaRPr>
@@ -39904,7 +39818,7 @@
               </a:rPr>
               <a:t>errors</a:t>
             </a:r>
-            <a:endParaRPr sz="2400">
+            <a:endParaRPr sz="2400" dirty="0">
               <a:latin typeface="Arial MT"/>
               <a:cs typeface="Arial MT"/>
             </a:endParaRPr>

</xml_diff>